<commit_message>
Refine documentation and templates: remove accent underscores from headers, update example sources, and enhance ingestion reports
</commit_message>
<xml_diff>
--- a/examples/example-source.pptx
+++ b/examples/example-source.pptx
@@ -1147,20 +1147,6 @@
                 <a:cs typeface="Inter" pitchFamily="34" charset="-120"/>
               </a:rPr>
               <a:t>Section header</a:t>
-            </a:r>
-            <a:pPr indent="0" marL="0">
-              <a:buNone/>
-            </a:pPr>
-            <a:r>
-              <a:rPr lang="en-US" sz="1400" dirty="0">
-                <a:solidFill>
-                  <a:srgbClr val="3B82F6"/>
-                </a:solidFill>
-                <a:latin typeface="Inter" pitchFamily="34" charset="0"/>
-                <a:ea typeface="Inter" pitchFamily="34" charset="-122"/>
-                <a:cs typeface="Inter" pitchFamily="34" charset="-120"/>
-              </a:rPr>
-              <a:t>_</a:t>
             </a:r>
             <a:endParaRPr lang="en-US" sz="1400" dirty="0"/>
           </a:p>

</xml_diff>